<commit_message>
feat: add transparent AxGS logo and disable chatbot UI sitewide
</commit_message>
<xml_diff>
--- a/data/DB시스템/0장_데이터베이스시스템_Preview.pptx
+++ b/data/DB시스템/0장_데이터베이스시스템_Preview.pptx
@@ -127,370 +127,6 @@
     </p:ext>
   </p:extLst>
 </p:presentation>
-</file>
-
-<file path=ppt/charts/chart1.xml><?xml version="1.0" encoding="utf-8"?>
-<c:chartSpace xmlns:c="http://schemas.openxmlformats.org/drawingml/2006/chart" xmlns:a="http://schemas.openxmlformats.org/drawingml/2006/main" xmlns:r="http://schemas.openxmlformats.org/officeDocument/2006/relationships" xmlns:c16r2="http://schemas.microsoft.com/office/drawing/2015/06/chart">
-  <c:date1904 val="0"/>
-  <c:lang val="ko-KR"/>
-  <c:roundedCorners val="1"/>
-  <c:style val="2"/>
-  <c:chart>
-    <c:autoTitleDeleted val="1"/>
-    <c:plotArea>
-      <c:layout/>
-      <c:doughnutChart>
-        <c:varyColors val="1"/>
-        <c:ser>
-          <c:idx val="0"/>
-          <c:order val="0"/>
-          <c:tx>
-            <c:strRef>
-              <c:f>Sheet1!$B$1</c:f>
-              <c:strCache>
-                <c:ptCount val="1"/>
-                <c:pt idx="0">
-                  <c:v>평가</c:v>
-                </c:pt>
-              </c:strCache>
-            </c:strRef>
-          </c:tx>
-          <c:spPr>
-            <a:solidFill>
-              <a:schemeClr val="accent1"/>
-            </a:solidFill>
-            <a:ln w="9525" cap="flat">
-              <a:solidFill>
-                <a:srgbClr val="F9F9F9"/>
-              </a:solidFill>
-              <a:prstDash val="solid"/>
-              <a:round/>
-            </a:ln>
-            <a:effectLst/>
-          </c:spPr>
-          <c:dPt>
-            <c:idx val="0"/>
-            <c:bubble3D val="0"/>
-            <c:spPr>
-              <a:solidFill>
-                <a:srgbClr val="0891B2"/>
-              </a:solidFill>
-              <a:effectLst/>
-            </c:spPr>
-            <c:extLst>
-              <c:ext xmlns:c16="http://schemas.microsoft.com/office/drawing/2014/chart" uri="{C3380CC4-5D6E-409C-BE32-E72D297353CC}">
-                <c16:uniqueId val="{00000001-A74D-4E4F-B49C-0437776F75B4}"/>
-              </c:ext>
-            </c:extLst>
-          </c:dPt>
-          <c:dPt>
-            <c:idx val="1"/>
-            <c:bubble3D val="0"/>
-            <c:spPr>
-              <a:solidFill>
-                <a:srgbClr val="F59E0B"/>
-              </a:solidFill>
-              <a:effectLst/>
-            </c:spPr>
-            <c:extLst>
-              <c:ext xmlns:c16="http://schemas.microsoft.com/office/drawing/2014/chart" uri="{C3380CC4-5D6E-409C-BE32-E72D297353CC}">
-                <c16:uniqueId val="{00000003-A74D-4E4F-B49C-0437776F75B4}"/>
-              </c:ext>
-            </c:extLst>
-          </c:dPt>
-          <c:dPt>
-            <c:idx val="2"/>
-            <c:bubble3D val="0"/>
-            <c:spPr>
-              <a:solidFill>
-                <a:srgbClr val="8B5CF6"/>
-              </a:solidFill>
-              <a:effectLst/>
-            </c:spPr>
-            <c:extLst>
-              <c:ext xmlns:c16="http://schemas.microsoft.com/office/drawing/2014/chart" uri="{C3380CC4-5D6E-409C-BE32-E72D297353CC}">
-                <c16:uniqueId val="{00000005-A74D-4E4F-B49C-0437776F75B4}"/>
-              </c:ext>
-            </c:extLst>
-          </c:dPt>
-          <c:dPt>
-            <c:idx val="3"/>
-            <c:bubble3D val="0"/>
-            <c:spPr>
-              <a:solidFill>
-                <a:srgbClr val="10B981"/>
-              </a:solidFill>
-              <a:effectLst/>
-            </c:spPr>
-            <c:extLst>
-              <c:ext xmlns:c16="http://schemas.microsoft.com/office/drawing/2014/chart" uri="{C3380CC4-5D6E-409C-BE32-E72D297353CC}">
-                <c16:uniqueId val="{00000007-A74D-4E4F-B49C-0437776F75B4}"/>
-              </c:ext>
-            </c:extLst>
-          </c:dPt>
-          <c:dLbls>
-            <c:dLbl>
-              <c:idx val="0"/>
-              <c:numFmt formatCode="0%" sourceLinked="0"/>
-              <c:spPr/>
-              <c:txPr>
-                <a:bodyPr/>
-                <a:lstStyle/>
-                <a:p>
-                  <a:pPr>
-                    <a:defRPr sz="1100" b="0" i="0" u="none" strike="noStrike">
-                      <a:solidFill>
-                        <a:srgbClr val="334155"/>
-                      </a:solidFill>
-                      <a:latin typeface="Arial"/>
-                    </a:defRPr>
-                  </a:pPr>
-                  <a:endParaRPr lang="ko-KR"/>
-                </a:p>
-              </c:txPr>
-              <c:showLegendKey val="0"/>
-              <c:showVal val="0"/>
-              <c:showCatName val="0"/>
-              <c:showSerName val="0"/>
-              <c:showPercent val="1"/>
-              <c:showBubbleSize val="0"/>
-              <c:extLst>
-                <c:ext xmlns:c15="http://schemas.microsoft.com/office/drawing/2012/chart" uri="{CE6537A1-D6FC-4f65-9D91-7224C49458BB}"/>
-                <c:ext xmlns:c16="http://schemas.microsoft.com/office/drawing/2014/chart" uri="{C3380CC4-5D6E-409C-BE32-E72D297353CC}">
-                  <c16:uniqueId val="{00000001-A74D-4E4F-B49C-0437776F75B4}"/>
-                </c:ext>
-              </c:extLst>
-            </c:dLbl>
-            <c:dLbl>
-              <c:idx val="1"/>
-              <c:numFmt formatCode="0%" sourceLinked="0"/>
-              <c:spPr/>
-              <c:txPr>
-                <a:bodyPr/>
-                <a:lstStyle/>
-                <a:p>
-                  <a:pPr>
-                    <a:defRPr sz="1100" b="0" i="0" u="none" strike="noStrike">
-                      <a:solidFill>
-                        <a:srgbClr val="334155"/>
-                      </a:solidFill>
-                      <a:latin typeface="Arial"/>
-                    </a:defRPr>
-                  </a:pPr>
-                  <a:endParaRPr lang="ko-KR"/>
-                </a:p>
-              </c:txPr>
-              <c:showLegendKey val="0"/>
-              <c:showVal val="0"/>
-              <c:showCatName val="0"/>
-              <c:showSerName val="0"/>
-              <c:showPercent val="1"/>
-              <c:showBubbleSize val="0"/>
-              <c:extLst>
-                <c:ext xmlns:c15="http://schemas.microsoft.com/office/drawing/2012/chart" uri="{CE6537A1-D6FC-4f65-9D91-7224C49458BB}"/>
-                <c:ext xmlns:c16="http://schemas.microsoft.com/office/drawing/2014/chart" uri="{C3380CC4-5D6E-409C-BE32-E72D297353CC}">
-                  <c16:uniqueId val="{00000003-A74D-4E4F-B49C-0437776F75B4}"/>
-                </c:ext>
-              </c:extLst>
-            </c:dLbl>
-            <c:dLbl>
-              <c:idx val="2"/>
-              <c:numFmt formatCode="0%" sourceLinked="0"/>
-              <c:spPr/>
-              <c:txPr>
-                <a:bodyPr/>
-                <a:lstStyle/>
-                <a:p>
-                  <a:pPr>
-                    <a:defRPr sz="1100" b="0" i="0" u="none" strike="noStrike">
-                      <a:solidFill>
-                        <a:srgbClr val="334155"/>
-                      </a:solidFill>
-                      <a:latin typeface="Arial"/>
-                    </a:defRPr>
-                  </a:pPr>
-                  <a:endParaRPr lang="ko-KR"/>
-                </a:p>
-              </c:txPr>
-              <c:showLegendKey val="0"/>
-              <c:showVal val="0"/>
-              <c:showCatName val="0"/>
-              <c:showSerName val="0"/>
-              <c:showPercent val="1"/>
-              <c:showBubbleSize val="0"/>
-              <c:extLst>
-                <c:ext xmlns:c15="http://schemas.microsoft.com/office/drawing/2012/chart" uri="{CE6537A1-D6FC-4f65-9D91-7224C49458BB}"/>
-                <c:ext xmlns:c16="http://schemas.microsoft.com/office/drawing/2014/chart" uri="{C3380CC4-5D6E-409C-BE32-E72D297353CC}">
-                  <c16:uniqueId val="{00000005-A74D-4E4F-B49C-0437776F75B4}"/>
-                </c:ext>
-              </c:extLst>
-            </c:dLbl>
-            <c:dLbl>
-              <c:idx val="3"/>
-              <c:numFmt formatCode="0%" sourceLinked="0"/>
-              <c:spPr/>
-              <c:txPr>
-                <a:bodyPr/>
-                <a:lstStyle/>
-                <a:p>
-                  <a:pPr>
-                    <a:defRPr sz="1100" b="0" i="0" u="none" strike="noStrike">
-                      <a:solidFill>
-                        <a:srgbClr val="334155"/>
-                      </a:solidFill>
-                      <a:latin typeface="Arial"/>
-                    </a:defRPr>
-                  </a:pPr>
-                  <a:endParaRPr lang="ko-KR"/>
-                </a:p>
-              </c:txPr>
-              <c:showLegendKey val="0"/>
-              <c:showVal val="0"/>
-              <c:showCatName val="0"/>
-              <c:showSerName val="0"/>
-              <c:showPercent val="1"/>
-              <c:showBubbleSize val="0"/>
-              <c:extLst>
-                <c:ext xmlns:c15="http://schemas.microsoft.com/office/drawing/2012/chart" uri="{CE6537A1-D6FC-4f65-9D91-7224C49458BB}"/>
-                <c:ext xmlns:c16="http://schemas.microsoft.com/office/drawing/2014/chart" uri="{C3380CC4-5D6E-409C-BE32-E72D297353CC}">
-                  <c16:uniqueId val="{00000007-A74D-4E4F-B49C-0437776F75B4}"/>
-                </c:ext>
-              </c:extLst>
-            </c:dLbl>
-            <c:numFmt formatCode="0%" sourceLinked="0"/>
-            <c:spPr>
-              <a:noFill/>
-              <a:ln>
-                <a:noFill/>
-              </a:ln>
-              <a:effectLst/>
-            </c:spPr>
-            <c:txPr>
-              <a:bodyPr/>
-              <a:lstStyle/>
-              <a:p>
-                <a:pPr>
-                  <a:defRPr sz="1800" b="0" i="0" u="none" strike="noStrike">
-                    <a:solidFill>
-                      <a:srgbClr val="000000"/>
-                    </a:solidFill>
-                    <a:latin typeface="Arial"/>
-                  </a:defRPr>
-                </a:pPr>
-                <a:endParaRPr lang="ko-KR"/>
-              </a:p>
-            </c:txPr>
-            <c:showLegendKey val="0"/>
-            <c:showVal val="0"/>
-            <c:showCatName val="1"/>
-            <c:showSerName val="0"/>
-            <c:showPercent val="1"/>
-            <c:showBubbleSize val="0"/>
-            <c:showLeaderLines val="0"/>
-            <c:extLst>
-              <c:ext xmlns:c15="http://schemas.microsoft.com/office/drawing/2012/chart" uri="{CE6537A1-D6FC-4f65-9D91-7224C49458BB}"/>
-            </c:extLst>
-          </c:dLbls>
-          <c:cat>
-            <c:strRef>
-              <c:f>Sheet1!$A$2:$A$5</c:f>
-              <c:strCache>
-                <c:ptCount val="4"/>
-                <c:pt idx="0">
-                  <c:v>퀴즈 및 과제</c:v>
-                </c:pt>
-                <c:pt idx="1">
-                  <c:v>중간고사</c:v>
-                </c:pt>
-                <c:pt idx="2">
-                  <c:v>기말고사</c:v>
-                </c:pt>
-                <c:pt idx="3">
-                  <c:v>출석</c:v>
-                </c:pt>
-              </c:strCache>
-            </c:strRef>
-          </c:cat>
-          <c:val>
-            <c:numRef>
-              <c:f>Sheet1!$B$2:$B$5</c:f>
-              <c:numCache>
-                <c:formatCode>General</c:formatCode>
-                <c:ptCount val="4"/>
-                <c:pt idx="0">
-                  <c:v>30</c:v>
-                </c:pt>
-                <c:pt idx="1">
-                  <c:v>30</c:v>
-                </c:pt>
-                <c:pt idx="2">
-                  <c:v>30</c:v>
-                </c:pt>
-                <c:pt idx="3">
-                  <c:v>10</c:v>
-                </c:pt>
-              </c:numCache>
-            </c:numRef>
-          </c:val>
-          <c:extLst>
-            <c:ext xmlns:c16="http://schemas.microsoft.com/office/drawing/2014/chart" uri="{C3380CC4-5D6E-409C-BE32-E72D297353CC}">
-              <c16:uniqueId val="{00000008-A74D-4E4F-B49C-0437776F75B4}"/>
-            </c:ext>
-          </c:extLst>
-        </c:ser>
-        <c:dLbls>
-          <c:showLegendKey val="0"/>
-          <c:showVal val="0"/>
-          <c:showCatName val="0"/>
-          <c:showSerName val="0"/>
-          <c:showPercent val="0"/>
-          <c:showBubbleSize val="0"/>
-          <c:showLeaderLines val="0"/>
-        </c:dLbls>
-        <c:firstSliceAng val="0"/>
-        <c:holeSize val="50"/>
-      </c:doughnutChart>
-      <c:spPr>
-        <a:noFill/>
-        <a:ln>
-          <a:noFill/>
-        </a:ln>
-        <a:effectLst/>
-      </c:spPr>
-    </c:plotArea>
-    <c:legend>
-      <c:legendPos val="b"/>
-      <c:overlay val="0"/>
-      <c:txPr>
-        <a:bodyPr/>
-        <a:lstStyle/>
-        <a:p>
-          <a:pPr>
-            <a:defRPr sz="1000">
-              <a:solidFill>
-                <a:srgbClr val="334155"/>
-              </a:solidFill>
-            </a:defRPr>
-          </a:pPr>
-          <a:endParaRPr lang="ko-KR"/>
-        </a:p>
-      </c:txPr>
-    </c:legend>
-    <c:plotVisOnly val="1"/>
-    <c:dispBlanksAs val="span"/>
-    <c:showDLblsOverMax val="1"/>
-  </c:chart>
-  <c:spPr>
-    <a:noFill/>
-    <a:ln>
-      <a:noFill/>
-    </a:ln>
-    <a:effectLst/>
-  </c:spPr>
-  <c:externalData r:id="rId1">
-    <c:autoUpdate val="0"/>
-  </c:externalData>
-</c:chartSpace>
 </file>
 
 <file path=ppt/notesMasters/notesMaster1.xml><?xml version="1.0" encoding="utf-8"?>
@@ -5324,22 +4960,6 @@
           </a:p>
         </p:txBody>
       </p:sp>
-      <p:graphicFrame>
-        <p:nvGraphicFramePr>
-          <p:cNvPr id="6" name="Chart 0"/>
-          <p:cNvGraphicFramePr/>
-          <p:nvPr/>
-        </p:nvGraphicFramePr>
-        <p:xfrm>
-          <a:off x="457200" y="1051560"/>
-          <a:ext cx="3474720" cy="3200400"/>
-        </p:xfrm>
-        <a:graphic>
-          <a:graphicData uri="http://schemas.openxmlformats.org/drawingml/2006/chart">
-            <c:chart xmlns:c="http://schemas.openxmlformats.org/drawingml/2006/chart" xmlns:r="http://schemas.openxmlformats.org/officeDocument/2006/relationships" r:id="rId3"/>
-          </a:graphicData>
-        </a:graphic>
-      </p:graphicFrame>
       <p:sp>
         <p:nvSpPr>
           <p:cNvPr id="7" name="Shape 4"/>
@@ -5348,8 +4968,8 @@
         </p:nvSpPr>
         <p:spPr>
           <a:xfrm>
-            <a:off x="4206240" y="1051560"/>
-            <a:ext cx="4297680" cy="777240"/>
+            <a:off x="731520" y="1051560"/>
+            <a:ext cx="6592824" cy="777240"/>
           </a:xfrm>
           <a:prstGeom prst="rect">
             <a:avLst/>
@@ -5375,7 +4995,7 @@
         </p:nvSpPr>
         <p:spPr>
           <a:xfrm>
-            <a:off x="4206240" y="1051560"/>
+            <a:off x="731520" y="1051560"/>
             <a:ext cx="64008" cy="777240"/>
           </a:xfrm>
           <a:prstGeom prst="rect">
@@ -5395,7 +5015,7 @@
         </p:nvSpPr>
         <p:spPr>
           <a:xfrm>
-            <a:off x="4389120" y="1097280"/>
+            <a:off x="914400" y="1097280"/>
             <a:ext cx="594360" cy="320040"/>
           </a:xfrm>
           <a:prstGeom prst="rect">
@@ -5420,7 +5040,7 @@
                 <a:ea typeface="Arial Black" pitchFamily="34" charset="-122"/>
                 <a:cs typeface="Arial Black" pitchFamily="34" charset="-120"/>
               </a:rPr>
-              <a:t>30%</a:t>
+              <a:t>10%</a:t>
             </a:r>
             <a:endParaRPr lang="en-US" sz="1600" dirty="0"/>
           </a:p>
@@ -5434,7 +5054,7 @@
         </p:nvSpPr>
         <p:spPr>
           <a:xfrm>
-            <a:off x="5029200" y="1097280"/>
+            <a:off x="1554480" y="1097280"/>
             <a:ext cx="3200400" cy="274320"/>
           </a:xfrm>
           <a:prstGeom prst="rect">
@@ -5473,8 +5093,8 @@
         </p:nvSpPr>
         <p:spPr>
           <a:xfrm>
-            <a:off x="4434840" y="1417320"/>
-            <a:ext cx="3840480" cy="365760"/>
+            <a:off x="960120" y="1417320"/>
+            <a:ext cx="6080760" cy="365760"/>
           </a:xfrm>
           <a:prstGeom prst="rect">
             <a:avLst/>
@@ -5515,8 +5135,8 @@
         </p:nvSpPr>
         <p:spPr>
           <a:xfrm>
-            <a:off x="4206240" y="2011680"/>
-            <a:ext cx="4297680" cy="777240"/>
+            <a:off x="731520" y="2011680"/>
+            <a:ext cx="6592824" cy="777240"/>
           </a:xfrm>
           <a:prstGeom prst="rect">
             <a:avLst/>
@@ -5542,7 +5162,7 @@
         </p:nvSpPr>
         <p:spPr>
           <a:xfrm>
-            <a:off x="4206240" y="2011680"/>
+            <a:off x="731520" y="2011680"/>
             <a:ext cx="64008" cy="777240"/>
           </a:xfrm>
           <a:prstGeom prst="rect">
@@ -5562,7 +5182,7 @@
         </p:nvSpPr>
         <p:spPr>
           <a:xfrm>
-            <a:off x="4389120" y="2057400"/>
+            <a:off x="914400" y="2057400"/>
             <a:ext cx="594360" cy="320040"/>
           </a:xfrm>
           <a:prstGeom prst="rect">
@@ -5587,7 +5207,7 @@
                 <a:ea typeface="Arial Black" pitchFamily="34" charset="-122"/>
                 <a:cs typeface="Arial Black" pitchFamily="34" charset="-120"/>
               </a:rPr>
-              <a:t>30%</a:t>
+              <a:t>40%</a:t>
             </a:r>
             <a:endParaRPr lang="en-US" sz="1600" dirty="0"/>
           </a:p>
@@ -5601,7 +5221,7 @@
         </p:nvSpPr>
         <p:spPr>
           <a:xfrm>
-            <a:off x="5029200" y="2057400"/>
+            <a:off x="1554480" y="2057400"/>
             <a:ext cx="3200400" cy="274320"/>
           </a:xfrm>
           <a:prstGeom prst="rect">
@@ -5640,8 +5260,8 @@
         </p:nvSpPr>
         <p:spPr>
           <a:xfrm>
-            <a:off x="4434840" y="2377440"/>
-            <a:ext cx="3840480" cy="365760"/>
+            <a:off x="960120" y="2377440"/>
+            <a:ext cx="6080760" cy="365760"/>
           </a:xfrm>
           <a:prstGeom prst="rect">
             <a:avLst/>
@@ -5682,8 +5302,8 @@
         </p:nvSpPr>
         <p:spPr>
           <a:xfrm>
-            <a:off x="4206240" y="2971800"/>
-            <a:ext cx="4297680" cy="777240"/>
+            <a:off x="731520" y="2971800"/>
+            <a:ext cx="6592824" cy="777240"/>
           </a:xfrm>
           <a:prstGeom prst="rect">
             <a:avLst/>
@@ -5709,7 +5329,7 @@
         </p:nvSpPr>
         <p:spPr>
           <a:xfrm>
-            <a:off x="4206240" y="2971800"/>
+            <a:off x="731520" y="2971800"/>
             <a:ext cx="64008" cy="777240"/>
           </a:xfrm>
           <a:prstGeom prst="rect">
@@ -5729,7 +5349,7 @@
         </p:nvSpPr>
         <p:spPr>
           <a:xfrm>
-            <a:off x="4389120" y="3017520"/>
+            <a:off x="914400" y="3017520"/>
             <a:ext cx="594360" cy="320040"/>
           </a:xfrm>
           <a:prstGeom prst="rect">
@@ -5754,7 +5374,7 @@
                 <a:ea typeface="Arial Black" pitchFamily="34" charset="-122"/>
                 <a:cs typeface="Arial Black" pitchFamily="34" charset="-120"/>
               </a:rPr>
-              <a:t>30%</a:t>
+              <a:t>40%</a:t>
             </a:r>
             <a:endParaRPr lang="en-US" sz="1600" dirty="0"/>
           </a:p>
@@ -5768,7 +5388,7 @@
         </p:nvSpPr>
         <p:spPr>
           <a:xfrm>
-            <a:off x="5029200" y="3017520"/>
+            <a:off x="1554480" y="3017520"/>
             <a:ext cx="3200400" cy="274320"/>
           </a:xfrm>
           <a:prstGeom prst="rect">
@@ -5807,8 +5427,8 @@
         </p:nvSpPr>
         <p:spPr>
           <a:xfrm>
-            <a:off x="4434840" y="3337560"/>
-            <a:ext cx="3840480" cy="365760"/>
+            <a:off x="960120" y="3337560"/>
+            <a:ext cx="6080760" cy="365760"/>
           </a:xfrm>
           <a:prstGeom prst="rect">
             <a:avLst/>
@@ -5849,8 +5469,8 @@
         </p:nvSpPr>
         <p:spPr>
           <a:xfrm>
-            <a:off x="4206240" y="3931920"/>
-            <a:ext cx="4297680" cy="777240"/>
+            <a:off x="731520" y="3931920"/>
+            <a:ext cx="6592824" cy="777240"/>
           </a:xfrm>
           <a:prstGeom prst="rect">
             <a:avLst/>
@@ -5876,7 +5496,7 @@
         </p:nvSpPr>
         <p:spPr>
           <a:xfrm>
-            <a:off x="4206240" y="3931920"/>
+            <a:off x="731520" y="3931920"/>
             <a:ext cx="64008" cy="777240"/>
           </a:xfrm>
           <a:prstGeom prst="rect">
@@ -5896,7 +5516,7 @@
         </p:nvSpPr>
         <p:spPr>
           <a:xfrm>
-            <a:off x="4389120" y="3977640"/>
+            <a:off x="914400" y="3977640"/>
             <a:ext cx="594360" cy="320040"/>
           </a:xfrm>
           <a:prstGeom prst="rect">
@@ -5935,7 +5555,7 @@
         </p:nvSpPr>
         <p:spPr>
           <a:xfrm>
-            <a:off x="5029200" y="3977640"/>
+            <a:off x="1554480" y="3977640"/>
             <a:ext cx="3200400" cy="274320"/>
           </a:xfrm>
           <a:prstGeom prst="rect">
@@ -5952,7 +5572,7 @@
               <a:buNone/>
             </a:pPr>
             <a:r>
-              <a:rPr lang="en-US" sz="1200" b="1" dirty="0">
+              <a:rPr lang="en-US" sz="1200" b="1" dirty="0" err="1">
                 <a:solidFill>
                   <a:srgbClr val="1A2744"/>
                 </a:solidFill>
@@ -5962,6 +5582,28 @@
               </a:rPr>
               <a:t>출석</a:t>
             </a:r>
+            <a:r>
+              <a:rPr lang="en-US" sz="1200" b="1" dirty="0">
+                <a:solidFill>
+                  <a:srgbClr val="1A2744"/>
+                </a:solidFill>
+                <a:latin typeface="Arial" pitchFamily="34" charset="0"/>
+                <a:ea typeface="Arial" pitchFamily="34" charset="-122"/>
+                <a:cs typeface="Arial" pitchFamily="34" charset="-120"/>
+              </a:rPr>
+              <a:t> </a:t>
+            </a:r>
+            <a:r>
+              <a:rPr lang="ko-KR" altLang="en-US" sz="1200" b="1" dirty="0">
+                <a:solidFill>
+                  <a:srgbClr val="1A2744"/>
+                </a:solidFill>
+                <a:latin typeface="Arial" pitchFamily="34" charset="0"/>
+                <a:ea typeface="Arial" pitchFamily="34" charset="-122"/>
+                <a:cs typeface="Arial" pitchFamily="34" charset="-120"/>
+              </a:rPr>
+              <a:t>및 핵심역량평가</a:t>
+            </a:r>
             <a:endParaRPr lang="en-US" sz="1200" dirty="0"/>
           </a:p>
         </p:txBody>
@@ -5974,8 +5616,8 @@
         </p:nvSpPr>
         <p:spPr>
           <a:xfrm>
-            <a:off x="4434840" y="4297680"/>
-            <a:ext cx="3840480" cy="365760"/>
+            <a:off x="960120" y="4297680"/>
+            <a:ext cx="6080760" cy="365760"/>
           </a:xfrm>
           <a:prstGeom prst="rect">
             <a:avLst/>
@@ -5987,14 +5629,13 @@
           <a:bodyPr wrap="square" lIns="0" tIns="0" rIns="0" bIns="0" rtlCol="0" anchor="ctr"/>
           <a:lstStyle/>
           <a:p>
-            <a:pPr marL="0" indent="0">
+            <a:pPr>
               <a:lnSpc>
                 <a:spcPct val="115000"/>
               </a:lnSpc>
-              <a:buNone/>
             </a:pPr>
             <a:r>
-              <a:rPr lang="en-US" sz="950" dirty="0">
+              <a:rPr lang="ko-KR" altLang="en-US" sz="950" dirty="0">
                 <a:solidFill>
                   <a:srgbClr val="334155"/>
                 </a:solidFill>
@@ -6002,9 +5643,239 @@
                 <a:ea typeface="Calibri" pitchFamily="34" charset="-122"/>
                 <a:cs typeface="Calibri" pitchFamily="34" charset="-120"/>
               </a:rPr>
-              <a:t>성실한 수업 참여를 평가합니다. 지각 3회 = 결석 1회로 처리됩니다. 전체 수업의 1/3 이상 결석 시 F 처리.</a:t>
-            </a:r>
-            <a:endParaRPr lang="en-US" sz="950" dirty="0"/>
+              <a:t>지각 </a:t>
+            </a:r>
+            <a:r>
+              <a:rPr lang="en-US" altLang="ko-KR" sz="950" dirty="0">
+                <a:solidFill>
+                  <a:srgbClr val="334155"/>
+                </a:solidFill>
+                <a:latin typeface="Calibri" pitchFamily="34" charset="0"/>
+                <a:ea typeface="Calibri" pitchFamily="34" charset="-122"/>
+                <a:cs typeface="Calibri" pitchFamily="34" charset="-120"/>
+              </a:rPr>
+              <a:t>3</a:t>
+            </a:r>
+            <a:r>
+              <a:rPr lang="ko-KR" altLang="en-US" sz="950" dirty="0">
+                <a:solidFill>
+                  <a:srgbClr val="334155"/>
+                </a:solidFill>
+                <a:latin typeface="Calibri" pitchFamily="34" charset="0"/>
+                <a:ea typeface="Calibri" pitchFamily="34" charset="-122"/>
+                <a:cs typeface="Calibri" pitchFamily="34" charset="-120"/>
+              </a:rPr>
+              <a:t>회 </a:t>
+            </a:r>
+            <a:r>
+              <a:rPr lang="en-US" altLang="ko-KR" sz="950" dirty="0">
+                <a:solidFill>
+                  <a:srgbClr val="334155"/>
+                </a:solidFill>
+                <a:latin typeface="Calibri" pitchFamily="34" charset="0"/>
+                <a:ea typeface="Calibri" pitchFamily="34" charset="-122"/>
+                <a:cs typeface="Calibri" pitchFamily="34" charset="-120"/>
+              </a:rPr>
+              <a:t>= </a:t>
+            </a:r>
+            <a:r>
+              <a:rPr lang="ko-KR" altLang="en-US" sz="950" dirty="0">
+                <a:solidFill>
+                  <a:srgbClr val="334155"/>
+                </a:solidFill>
+                <a:latin typeface="Calibri" pitchFamily="34" charset="0"/>
+                <a:ea typeface="Calibri" pitchFamily="34" charset="-122"/>
+                <a:cs typeface="Calibri" pitchFamily="34" charset="-120"/>
+              </a:rPr>
+              <a:t>결석 </a:t>
+            </a:r>
+            <a:r>
+              <a:rPr lang="en-US" altLang="ko-KR" sz="950" dirty="0">
+                <a:solidFill>
+                  <a:srgbClr val="334155"/>
+                </a:solidFill>
+                <a:latin typeface="Calibri" pitchFamily="34" charset="0"/>
+                <a:ea typeface="Calibri" pitchFamily="34" charset="-122"/>
+                <a:cs typeface="Calibri" pitchFamily="34" charset="-120"/>
+              </a:rPr>
+              <a:t>1</a:t>
+            </a:r>
+            <a:r>
+              <a:rPr lang="ko-KR" altLang="en-US" sz="950" dirty="0">
+                <a:solidFill>
+                  <a:srgbClr val="334155"/>
+                </a:solidFill>
+                <a:latin typeface="Calibri" pitchFamily="34" charset="0"/>
+                <a:ea typeface="Calibri" pitchFamily="34" charset="-122"/>
+                <a:cs typeface="Calibri" pitchFamily="34" charset="-120"/>
+              </a:rPr>
+              <a:t>회</a:t>
+            </a:r>
+            <a:r>
+              <a:rPr lang="en-US" altLang="ko-KR" sz="950" dirty="0">
+                <a:solidFill>
+                  <a:srgbClr val="334155"/>
+                </a:solidFill>
+                <a:latin typeface="Calibri" pitchFamily="34" charset="0"/>
+                <a:ea typeface="Calibri" pitchFamily="34" charset="-122"/>
+                <a:cs typeface="Calibri" pitchFamily="34" charset="-120"/>
+              </a:rPr>
+              <a:t>, </a:t>
+            </a:r>
+            <a:r>
+              <a:rPr lang="ko-KR" altLang="en-US" sz="950" dirty="0">
+                <a:solidFill>
+                  <a:srgbClr val="334155"/>
+                </a:solidFill>
+                <a:latin typeface="Calibri" pitchFamily="34" charset="0"/>
+                <a:ea typeface="Calibri" pitchFamily="34" charset="-122"/>
+                <a:cs typeface="Calibri" pitchFamily="34" charset="-120"/>
+              </a:rPr>
+              <a:t>결석 </a:t>
+            </a:r>
+            <a:r>
+              <a:rPr lang="en-US" altLang="ko-KR" sz="950" dirty="0">
+                <a:solidFill>
+                  <a:srgbClr val="334155"/>
+                </a:solidFill>
+                <a:latin typeface="Calibri" pitchFamily="34" charset="0"/>
+                <a:ea typeface="Calibri" pitchFamily="34" charset="-122"/>
+                <a:cs typeface="Calibri" pitchFamily="34" charset="-120"/>
+              </a:rPr>
+              <a:t>2</a:t>
+            </a:r>
+            <a:r>
+              <a:rPr lang="ko-KR" altLang="en-US" sz="950" dirty="0">
+                <a:solidFill>
+                  <a:srgbClr val="334155"/>
+                </a:solidFill>
+                <a:latin typeface="Calibri" pitchFamily="34" charset="0"/>
+                <a:ea typeface="Calibri" pitchFamily="34" charset="-122"/>
+                <a:cs typeface="Calibri" pitchFamily="34" charset="-120"/>
+              </a:rPr>
+              <a:t>회까지는 </a:t>
+            </a:r>
+            <a:r>
+              <a:rPr lang="en-US" altLang="ko-KR" sz="950" dirty="0">
+                <a:solidFill>
+                  <a:srgbClr val="334155"/>
+                </a:solidFill>
+                <a:latin typeface="Calibri" pitchFamily="34" charset="0"/>
+                <a:ea typeface="Calibri" pitchFamily="34" charset="-122"/>
+                <a:cs typeface="Calibri" pitchFamily="34" charset="-120"/>
+              </a:rPr>
+              <a:t>5</a:t>
+            </a:r>
+            <a:r>
+              <a:rPr lang="ko-KR" altLang="en-US" sz="950" dirty="0">
+                <a:solidFill>
+                  <a:srgbClr val="334155"/>
+                </a:solidFill>
+                <a:latin typeface="Calibri" pitchFamily="34" charset="0"/>
+                <a:ea typeface="Calibri" pitchFamily="34" charset="-122"/>
+                <a:cs typeface="Calibri" pitchFamily="34" charset="-120"/>
+              </a:rPr>
+              <a:t>점 만점</a:t>
+            </a:r>
+            <a:r>
+              <a:rPr lang="en-US" altLang="ko-KR" sz="950" dirty="0">
+                <a:solidFill>
+                  <a:srgbClr val="334155"/>
+                </a:solidFill>
+                <a:latin typeface="Calibri" pitchFamily="34" charset="0"/>
+                <a:ea typeface="Calibri" pitchFamily="34" charset="-122"/>
+                <a:cs typeface="Calibri" pitchFamily="34" charset="-120"/>
+              </a:rPr>
+              <a:t>, </a:t>
+            </a:r>
+            <a:r>
+              <a:rPr lang="ko-KR" altLang="en-US" sz="950" dirty="0">
+                <a:solidFill>
+                  <a:srgbClr val="334155"/>
+                </a:solidFill>
+                <a:latin typeface="Calibri" pitchFamily="34" charset="0"/>
+                <a:ea typeface="Calibri" pitchFamily="34" charset="-122"/>
+                <a:cs typeface="Calibri" pitchFamily="34" charset="-120"/>
+              </a:rPr>
+              <a:t>결석 </a:t>
+            </a:r>
+            <a:r>
+              <a:rPr lang="en-US" altLang="ko-KR" sz="950" dirty="0">
+                <a:solidFill>
+                  <a:srgbClr val="334155"/>
+                </a:solidFill>
+                <a:latin typeface="Calibri" pitchFamily="34" charset="0"/>
+                <a:ea typeface="Calibri" pitchFamily="34" charset="-122"/>
+                <a:cs typeface="Calibri" pitchFamily="34" charset="-120"/>
+              </a:rPr>
+              <a:t>3</a:t>
+            </a:r>
+            <a:r>
+              <a:rPr lang="ko-KR" altLang="en-US" sz="950" dirty="0">
+                <a:solidFill>
+                  <a:srgbClr val="334155"/>
+                </a:solidFill>
+                <a:latin typeface="Calibri" pitchFamily="34" charset="0"/>
+                <a:ea typeface="Calibri" pitchFamily="34" charset="-122"/>
+                <a:cs typeface="Calibri" pitchFamily="34" charset="-120"/>
+              </a:rPr>
+              <a:t>회부터 결석 </a:t>
+            </a:r>
+            <a:r>
+              <a:rPr lang="en-US" altLang="ko-KR" sz="950" dirty="0">
+                <a:solidFill>
+                  <a:srgbClr val="334155"/>
+                </a:solidFill>
+                <a:latin typeface="Calibri" pitchFamily="34" charset="0"/>
+                <a:ea typeface="Calibri" pitchFamily="34" charset="-122"/>
+                <a:cs typeface="Calibri" pitchFamily="34" charset="-120"/>
+              </a:rPr>
+              <a:t>2</a:t>
+            </a:r>
+            <a:r>
+              <a:rPr lang="ko-KR" altLang="en-US" sz="950" dirty="0">
+                <a:solidFill>
+                  <a:srgbClr val="334155"/>
+                </a:solidFill>
+                <a:latin typeface="Calibri" pitchFamily="34" charset="0"/>
+                <a:ea typeface="Calibri" pitchFamily="34" charset="-122"/>
+                <a:cs typeface="Calibri" pitchFamily="34" charset="-120"/>
+              </a:rPr>
+              <a:t>회마다 </a:t>
+            </a:r>
+            <a:r>
+              <a:rPr lang="en-US" altLang="ko-KR" sz="950" dirty="0">
+                <a:solidFill>
+                  <a:srgbClr val="334155"/>
+                </a:solidFill>
+                <a:latin typeface="Calibri" pitchFamily="34" charset="0"/>
+                <a:ea typeface="Calibri" pitchFamily="34" charset="-122"/>
+                <a:cs typeface="Calibri" pitchFamily="34" charset="-120"/>
+              </a:rPr>
+              <a:t>1</a:t>
+            </a:r>
+            <a:r>
+              <a:rPr lang="ko-KR" altLang="en-US" sz="950" dirty="0" err="1">
+                <a:solidFill>
+                  <a:srgbClr val="334155"/>
+                </a:solidFill>
+                <a:latin typeface="Calibri" pitchFamily="34" charset="0"/>
+                <a:ea typeface="Calibri" pitchFamily="34" charset="-122"/>
+                <a:cs typeface="Calibri" pitchFamily="34" charset="-120"/>
+              </a:rPr>
+              <a:t>점씩</a:t>
+            </a:r>
+            <a:r>
+              <a:rPr lang="ko-KR" altLang="en-US" sz="950" dirty="0">
+                <a:solidFill>
+                  <a:srgbClr val="334155"/>
+                </a:solidFill>
+                <a:latin typeface="Calibri" pitchFamily="34" charset="0"/>
+                <a:ea typeface="Calibri" pitchFamily="34" charset="-122"/>
+                <a:cs typeface="Calibri" pitchFamily="34" charset="-120"/>
+              </a:rPr>
+              <a:t> 차감</a:t>
+            </a:r>
           </a:p>
         </p:txBody>
       </p:sp>

</xml_diff>

<commit_message>
chore: refresh db systems preview pptx and pdf
</commit_message>
<xml_diff>
--- a/data/DB시스템/0장_데이터베이스시스템_Preview.pptx
+++ b/data/DB시스템/0장_데이터베이스시스템_Preview.pptx
@@ -6706,7 +6706,7 @@
           <p:nvPr>
             <p:extLst>
               <p:ext uri="{D42A27DB-BD31-4B8C-83A1-F6EECF244321}">
-                <p14:modId xmlns:p14="http://schemas.microsoft.com/office/powerpoint/2010/main" val="1579011935"/>
+                <p14:modId xmlns:p14="http://schemas.microsoft.com/office/powerpoint/2010/main" val="1248181471"/>
               </p:ext>
             </p:extLst>
           </p:nvPr>
@@ -6997,14 +6997,10 @@
                         <a:buNone/>
                       </a:pPr>
                       <a:r>
-                        <a:rPr lang="en-US" sz="1000" b="1" dirty="0">
-                          <a:solidFill>
-                            <a:srgbClr val="000000"/>
-                          </a:solidFill>
-                        </a:rPr>
-                        <a:t>수</a:t>
+                        <a:rPr lang="ko-KR" altLang="en-US" sz="1000" b="1" dirty="0"/>
+                        <a:t>목</a:t>
                       </a:r>
-                      <a:endParaRPr lang="en-US" sz="1000" dirty="0"/>
+                      <a:endParaRPr lang="en-US" sz="1000" b="1" dirty="0"/>
                     </a:p>
                   </a:txBody>
                   <a:tcPr>
@@ -7058,12 +7054,12 @@
                         <a:buNone/>
                       </a:pPr>
                       <a:r>
-                        <a:rPr lang="en-US" sz="1000" dirty="0">
+                        <a:rPr lang="en-US" sz="1000">
                           <a:solidFill>
                             <a:srgbClr val="000000"/>
                           </a:solidFill>
                         </a:rPr>
-                        <a:t>14:00 ~ 15:00</a:t>
+                        <a:t>12:00 ~ 13:00</a:t>
                       </a:r>
                       <a:endParaRPr lang="en-US" sz="1000" dirty="0"/>
                     </a:p>

</xml_diff>

<commit_message>
feat: update ai and db course materials
</commit_message>
<xml_diff>
--- a/data/DB시스템/0장_데이터베이스시스템_Preview.pptx
+++ b/data/DB시스템/0장_데이터베이스시스템_Preview.pptx
@@ -2341,8 +2341,21 @@
             <a:pPr marL="0" indent="0">
               <a:buNone/>
             </a:pPr>
-            <a:r>
-              <a:rPr lang="en-US" sz="1400" dirty="0">
+            <a:endParaRPr lang="en-US" sz="1400" dirty="0">
+              <a:solidFill>
+                <a:srgbClr val="94A3B8"/>
+              </a:solidFill>
+              <a:latin typeface="Calibri" pitchFamily="34" charset="0"/>
+              <a:ea typeface="Calibri" pitchFamily="34" charset="-122"/>
+              <a:cs typeface="Calibri" pitchFamily="34" charset="-120"/>
+            </a:endParaRPr>
+          </a:p>
+          <a:p>
+            <a:pPr marL="0" indent="0">
+              <a:buNone/>
+            </a:pPr>
+            <a:r>
+              <a:rPr lang="en-US" sz="1400" dirty="0" err="1">
                 <a:solidFill>
                   <a:srgbClr val="94A3B8"/>
                 </a:solidFill>
@@ -2350,9 +2363,33 @@
                 <a:ea typeface="Calibri" pitchFamily="34" charset="-122"/>
                 <a:cs typeface="Calibri" pitchFamily="34" charset="-120"/>
               </a:rPr>
-              <a:t>대전대학교 컴퓨터공학과</a:t>
+              <a:t>대전대학교</a:t>
+            </a:r>
+            <a:r>
+              <a:rPr lang="en-US" sz="1400" dirty="0">
+                <a:solidFill>
+                  <a:srgbClr val="94A3B8"/>
+                </a:solidFill>
+                <a:latin typeface="Calibri" pitchFamily="34" charset="0"/>
+                <a:ea typeface="Calibri" pitchFamily="34" charset="-122"/>
+                <a:cs typeface="Calibri" pitchFamily="34" charset="-120"/>
+              </a:rPr>
+              <a:t> 컴퓨터공학과</a:t>
             </a:r>
             <a:endParaRPr lang="en-US" sz="1800" dirty="0"/>
+          </a:p>
+          <a:p>
+            <a:pPr marL="0" indent="0">
+              <a:buNone/>
+            </a:pPr>
+            <a:endParaRPr lang="en-US" sz="1200" dirty="0">
+              <a:solidFill>
+                <a:srgbClr val="0891B2"/>
+              </a:solidFill>
+              <a:latin typeface="Calibri" pitchFamily="34" charset="0"/>
+              <a:ea typeface="Calibri" pitchFamily="34" charset="-122"/>
+              <a:cs typeface="Calibri" pitchFamily="34" charset="-120"/>
+            </a:endParaRPr>
           </a:p>
           <a:p>
             <a:pPr marL="0" indent="0">
@@ -5040,7 +5077,7 @@
                 <a:ea typeface="Arial Black" pitchFamily="34" charset="-122"/>
                 <a:cs typeface="Arial Black" pitchFamily="34" charset="-120"/>
               </a:rPr>
-              <a:t>10%</a:t>
+              <a:t>5%</a:t>
             </a:r>
             <a:endParaRPr lang="en-US" sz="1600" dirty="0"/>
           </a:p>
@@ -5541,7 +5578,7 @@
                 <a:ea typeface="Arial Black" pitchFamily="34" charset="-122"/>
                 <a:cs typeface="Arial Black" pitchFamily="34" charset="-120"/>
               </a:rPr>
-              <a:t>10%</a:t>
+              <a:t>15%</a:t>
             </a:r>
             <a:endParaRPr lang="en-US" sz="1600" dirty="0"/>
           </a:p>
@@ -5742,7 +5779,7 @@
                 <a:ea typeface="Calibri" pitchFamily="34" charset="-122"/>
                 <a:cs typeface="Calibri" pitchFamily="34" charset="-120"/>
               </a:rPr>
-              <a:t>2</a:t>
+              <a:t>1/3 </a:t>
             </a:r>
             <a:r>
               <a:rPr lang="ko-KR" altLang="en-US" sz="950" dirty="0">
@@ -5753,7 +5790,7 @@
                 <a:ea typeface="Calibri" pitchFamily="34" charset="-122"/>
                 <a:cs typeface="Calibri" pitchFamily="34" charset="-120"/>
               </a:rPr>
-              <a:t>회까지는 </a:t>
+              <a:t>이상이면 </a:t>
             </a:r>
             <a:r>
               <a:rPr lang="en-US" altLang="ko-KR" sz="950" dirty="0">
@@ -5764,7 +5801,7 @@
                 <a:ea typeface="Calibri" pitchFamily="34" charset="-122"/>
                 <a:cs typeface="Calibri" pitchFamily="34" charset="-120"/>
               </a:rPr>
-              <a:t>5</a:t>
+              <a:t>F </a:t>
             </a:r>
             <a:r>
               <a:rPr lang="ko-KR" altLang="en-US" sz="950" dirty="0">
@@ -5775,106 +5812,7 @@
                 <a:ea typeface="Calibri" pitchFamily="34" charset="-122"/>
                 <a:cs typeface="Calibri" pitchFamily="34" charset="-120"/>
               </a:rPr>
-              <a:t>점 만점</a:t>
-            </a:r>
-            <a:r>
-              <a:rPr lang="en-US" altLang="ko-KR" sz="950" dirty="0">
-                <a:solidFill>
-                  <a:srgbClr val="334155"/>
-                </a:solidFill>
-                <a:latin typeface="Calibri" pitchFamily="34" charset="0"/>
-                <a:ea typeface="Calibri" pitchFamily="34" charset="-122"/>
-                <a:cs typeface="Calibri" pitchFamily="34" charset="-120"/>
-              </a:rPr>
-              <a:t>, </a:t>
-            </a:r>
-            <a:r>
-              <a:rPr lang="ko-KR" altLang="en-US" sz="950" dirty="0">
-                <a:solidFill>
-                  <a:srgbClr val="334155"/>
-                </a:solidFill>
-                <a:latin typeface="Calibri" pitchFamily="34" charset="0"/>
-                <a:ea typeface="Calibri" pitchFamily="34" charset="-122"/>
-                <a:cs typeface="Calibri" pitchFamily="34" charset="-120"/>
-              </a:rPr>
-              <a:t>결석 </a:t>
-            </a:r>
-            <a:r>
-              <a:rPr lang="en-US" altLang="ko-KR" sz="950" dirty="0">
-                <a:solidFill>
-                  <a:srgbClr val="334155"/>
-                </a:solidFill>
-                <a:latin typeface="Calibri" pitchFamily="34" charset="0"/>
-                <a:ea typeface="Calibri" pitchFamily="34" charset="-122"/>
-                <a:cs typeface="Calibri" pitchFamily="34" charset="-120"/>
-              </a:rPr>
-              <a:t>3</a:t>
-            </a:r>
-            <a:r>
-              <a:rPr lang="ko-KR" altLang="en-US" sz="950" dirty="0">
-                <a:solidFill>
-                  <a:srgbClr val="334155"/>
-                </a:solidFill>
-                <a:latin typeface="Calibri" pitchFamily="34" charset="0"/>
-                <a:ea typeface="Calibri" pitchFamily="34" charset="-122"/>
-                <a:cs typeface="Calibri" pitchFamily="34" charset="-120"/>
-              </a:rPr>
-              <a:t>회부터 결석 </a:t>
-            </a:r>
-            <a:r>
-              <a:rPr lang="en-US" altLang="ko-KR" sz="950" dirty="0">
-                <a:solidFill>
-                  <a:srgbClr val="334155"/>
-                </a:solidFill>
-                <a:latin typeface="Calibri" pitchFamily="34" charset="0"/>
-                <a:ea typeface="Calibri" pitchFamily="34" charset="-122"/>
-                <a:cs typeface="Calibri" pitchFamily="34" charset="-120"/>
-              </a:rPr>
-              <a:t>2</a:t>
-            </a:r>
-            <a:r>
-              <a:rPr lang="ko-KR" altLang="en-US" sz="950" dirty="0">
-                <a:solidFill>
-                  <a:srgbClr val="334155"/>
-                </a:solidFill>
-                <a:latin typeface="Calibri" pitchFamily="34" charset="0"/>
-                <a:ea typeface="Calibri" pitchFamily="34" charset="-122"/>
-                <a:cs typeface="Calibri" pitchFamily="34" charset="-120"/>
-              </a:rPr>
-              <a:t>회마다 </a:t>
-            </a:r>
-            <a:r>
-              <a:rPr lang="en-US" altLang="ko-KR" sz="950" dirty="0">
-                <a:solidFill>
-                  <a:srgbClr val="334155"/>
-                </a:solidFill>
-                <a:latin typeface="Calibri" pitchFamily="34" charset="0"/>
-                <a:ea typeface="Calibri" pitchFamily="34" charset="-122"/>
-                <a:cs typeface="Calibri" pitchFamily="34" charset="-120"/>
-              </a:rPr>
-              <a:t>1</a:t>
-            </a:r>
-            <a:r>
-              <a:rPr lang="ko-KR" altLang="en-US" sz="950" dirty="0" err="1">
-                <a:solidFill>
-                  <a:srgbClr val="334155"/>
-                </a:solidFill>
-                <a:latin typeface="Calibri" pitchFamily="34" charset="0"/>
-                <a:ea typeface="Calibri" pitchFamily="34" charset="-122"/>
-                <a:cs typeface="Calibri" pitchFamily="34" charset="-120"/>
-              </a:rPr>
-              <a:t>점씩</a:t>
-            </a:r>
-            <a:r>
-              <a:rPr lang="ko-KR" altLang="en-US" sz="950" dirty="0">
-                <a:solidFill>
-                  <a:srgbClr val="334155"/>
-                </a:solidFill>
-                <a:latin typeface="Calibri" pitchFamily="34" charset="0"/>
-                <a:ea typeface="Calibri" pitchFamily="34" charset="-122"/>
-                <a:cs typeface="Calibri" pitchFamily="34" charset="-120"/>
-              </a:rPr>
-              <a:t> 차감</a:t>
+              <a:t>처리</a:t>
             </a:r>
           </a:p>
         </p:txBody>
@@ -6573,7 +6511,23 @@
                   <a:srgbClr val="0891B2"/>
                 </a:solidFill>
               </a:rPr>
-              <a:t>이메일: </a:t>
+              <a:t>이메일</a:t>
+            </a:r>
+            <a:r>
+              <a:rPr lang="en-US" sz="1000" b="1">
+                <a:solidFill>
+                  <a:srgbClr val="0891B2"/>
+                </a:solidFill>
+              </a:rPr>
+              <a:t>: </a:t>
+            </a:r>
+            <a:r>
+              <a:rPr lang="en-US" altLang="ko-KR" sz="1000">
+                <a:solidFill>
+                  <a:srgbClr val="334155"/>
+                </a:solidFill>
+              </a:rPr>
+              <a:t>sangdonpark</a:t>
             </a:r>
             <a:r>
               <a:rPr lang="en-US" altLang="ko-KR" sz="1000" dirty="0">
@@ -6581,7 +6535,7 @@
                   <a:srgbClr val="334155"/>
                 </a:solidFill>
               </a:rPr>
-              <a:t>sangdon.park@dju.kr</a:t>
+              <a:t>@dju.kr</a:t>
             </a:r>
             <a:endParaRPr lang="en-US" sz="1000" dirty="0"/>
           </a:p>
@@ -6706,7 +6660,7 @@
           <p:nvPr>
             <p:extLst>
               <p:ext uri="{D42A27DB-BD31-4B8C-83A1-F6EECF244321}">
-                <p14:modId xmlns:p14="http://schemas.microsoft.com/office/powerpoint/2010/main" val="1248181471"/>
+                <p14:modId xmlns:p14="http://schemas.microsoft.com/office/powerpoint/2010/main" val="4022907780"/>
               </p:ext>
             </p:extLst>
           </p:nvPr>
@@ -6879,7 +6833,7 @@
                             <a:srgbClr val="000000"/>
                           </a:solidFill>
                         </a:rPr>
-                        <a:t>월 / 화</a:t>
+                        <a:t>월 </a:t>
                       </a:r>
                       <a:endParaRPr lang="en-US" sz="1000" dirty="0"/>
                     </a:p>
@@ -6998,7 +6952,7 @@
                       </a:pPr>
                       <a:r>
                         <a:rPr lang="ko-KR" altLang="en-US" sz="1000" b="1" dirty="0"/>
-                        <a:t>목</a:t>
+                        <a:t>화</a:t>
                       </a:r>
                       <a:endParaRPr lang="en-US" sz="1000" b="1" dirty="0"/>
                     </a:p>
@@ -7050,16 +7004,38 @@
                     <a:bodyPr/>
                     <a:lstStyle/>
                     <a:p>
-                      <a:pPr marL="0" indent="0" algn="ctr">
+                      <a:pPr marL="0" marR="0" lvl="0" indent="0" algn="ctr" defTabSz="914400" rtl="0" eaLnBrk="1" fontAlgn="auto" latinLnBrk="0" hangingPunct="1">
+                        <a:lnSpc>
+                          <a:spcPct val="100000"/>
+                        </a:lnSpc>
+                        <a:spcBef>
+                          <a:spcPts val="0"/>
+                        </a:spcBef>
+                        <a:spcAft>
+                          <a:spcPts val="0"/>
+                        </a:spcAft>
+                        <a:buClrTx/>
+                        <a:buSzTx/>
+                        <a:buFontTx/>
                         <a:buNone/>
+                        <a:tabLst/>
+                        <a:defRPr/>
                       </a:pPr>
                       <a:r>
-                        <a:rPr lang="en-US" sz="1000">
+                        <a:rPr lang="en-US" altLang="ko-KR" sz="1000" dirty="0">
                           <a:solidFill>
                             <a:srgbClr val="000000"/>
                           </a:solidFill>
                         </a:rPr>
-                        <a:t>12:00 ~ 13:00</a:t>
+                        <a:t>11:00 ~ 12:00</a:t>
+                      </a:r>
+                      <a:r>
+                        <a:rPr lang="en-US" altLang="ko-KR" sz="1000" dirty="0">
+                          <a:solidFill>
+                            <a:schemeClr val="tx1"/>
+                          </a:solidFill>
+                        </a:rPr>
+                        <a:t>, 15:00 ~ 16:00</a:t>
                       </a:r>
                       <a:endParaRPr lang="en-US" sz="1000" dirty="0"/>
                     </a:p>

</xml_diff>